<commit_message>
Trust as fraud prevention in the deck and README; scenario statuses up to date
- Deck: a "Trust built in: fraud prevention" slide after the Google Cloud stack slide (same layout and styles):
  one-time pickup/booking pass, Ed25519 receipts that refuse edits, Model Armor on other agents' messages,
  per-buyer limits and atomic stock holds, seller record from signed receipts, App Check, demo payments tagged
- README: Trust and fraud prevention section, and a short section on the new retail features
- SCENARIOS-RETAIL: journeys built on 17 Oct marked done, tally recounted from the rows (93 / 11 / 8),
  and a Business insights note (shop insights now; BigQuery export and AI.FORECAST once access is granted)

The PDF was not regenerated (LibreOffice is not installed here).

Co-Authored-By: Claude Opus 5.5 <noreply@anthropic.com>
Signed-off-by: Atishay Srivastava <atishay.srivastava.10@gmail.com>
</commit_message>
<xml_diff>
--- a/submission/Collab_AI_Builder_Cup_Submission.pptx
+++ b/submission/Collab_AI_Builder_Cup_Submission.pptx
@@ -16,6 +16,7 @@
     <p:sldId xmlns:r="http://schemas.openxmlformats.org/officeDocument/2006/relationships" id="261" r:id="Raabcb0ead37f4415"/>
     <p:sldId xmlns:r="http://schemas.openxmlformats.org/officeDocument/2006/relationships" id="262" r:id="R6401ff533cb3442a"/>
     <p:sldId xmlns:r="http://schemas.openxmlformats.org/officeDocument/2006/relationships" id="263" r:id="R1932408c88fd490f"/>
+    <p:sldId xmlns:ns0="http://schemas.openxmlformats.org/officeDocument/2006/relationships" id="270" ns0:id="rId27"/>
     <p:sldId xmlns:r="http://schemas.openxmlformats.org/officeDocument/2006/relationships" id="264" r:id="R48e5e01226ff41fb"/>
     <p:sldId xmlns:r="http://schemas.openxmlformats.org/officeDocument/2006/relationships" id="265" r:id="R5bc169fd78004ed4"/>
     <p:sldId xmlns:r="http://schemas.openxmlformats.org/officeDocument/2006/relationships" id="266" r:id="R0d803720f47c487f"/>
@@ -931,6 +932,76 @@
   </p:cSld>
   <p:clrMapOvr>
     <a:masterClrMapping xmlns:a="http://schemas.openxmlformats.org/drawingml/2006/main"/>
+  </p:clrMapOvr>
+</p:notes>
+</file>
+
+<file path=ppt/notesSlides/notesSlide15.xml><?xml version="1.0" encoding="utf-8"?>
+<p:notes xmlns:a="http://schemas.openxmlformats.org/drawingml/2006/main" xmlns:p="http://schemas.openxmlformats.org/presentationml/2006/main" xmlns:r="http://schemas.openxmlformats.org/officeDocument/2006/relationships">
+  <p:cSld>
+    <p:spTree>
+      <p:nvGrpSpPr>
+        <p:cNvPr id="1" name=""/>
+        <p:cNvGrpSpPr/>
+        <p:nvPr/>
+      </p:nvGrpSpPr>
+      <p:grpSpPr>
+        <a:xfrm>
+          <a:off x="0" y="0"/>
+          <a:ext cx="0" cy="0"/>
+          <a:chOff x="0" y="0"/>
+          <a:chExt cx="0" cy="0"/>
+        </a:xfrm>
+      </p:grpSpPr>
+      <p:sp>
+        <p:nvSpPr>
+          <p:cNvPr id="2" name="Slide Image Placeholder 1"/>
+          <p:cNvSpPr>
+            <a:spLocks noGrp="1"/>
+          </p:cNvSpPr>
+          <p:nvPr>
+            <p:ph type="sldImg" idx="2"/>
+          </p:nvPr>
+        </p:nvSpPr>
+        <p:spPr/>
+      </p:sp>
+      <p:sp>
+        <p:nvSpPr>
+          <p:cNvPr id="3" name="Notes Placeholder 2"/>
+          <p:cNvSpPr>
+            <a:spLocks noGrp="1"/>
+          </p:cNvSpPr>
+          <p:nvPr>
+            <p:ph type="body" idx="3" sz="quarter"/>
+          </p:nvPr>
+        </p:nvSpPr>
+        <p:spPr/>
+        <p:txBody>
+          <a:bodyPr/>
+          <a:lstStyle/>
+          <a:p>
+            <a:r>
+              <a:t>Implementation references: server/src/core (pickup pass, receipts, armor, deals) and web/verify.html. Payments are simulated test-mode objects; no real money moves.</a:t>
+            </a:r>
+          </a:p>
+        </p:txBody>
+      </p:sp>
+      <p:sp>
+        <p:nvSpPr>
+          <p:cNvPr id="4" name="Slide Number Placeholder 3"/>
+          <p:cNvSpPr>
+            <a:spLocks noGrp="1"/>
+          </p:cNvSpPr>
+          <p:nvPr>
+            <p:ph type="sldNum" idx="5" sz="quarter"/>
+          </p:nvPr>
+        </p:nvSpPr>
+        <p:spPr/>
+      </p:sp>
+    </p:spTree>
+  </p:cSld>
+  <p:clrMapOvr>
+    <a:masterClrMapping/>
   </p:clrMapOvr>
 </p:notes>
 </file>
@@ -9665,6 +9736,1179 @@
 </p:sld>
 </file>
 
+<file path=ppt/slides/slide15.xml><?xml version="1.0" encoding="utf-8"?>
+<p:sld xmlns:a="http://schemas.openxmlformats.org/drawingml/2006/main" xmlns:p="http://schemas.openxmlformats.org/presentationml/2006/main" xmlns:r="http://schemas.openxmlformats.org/officeDocument/2006/relationships">
+  <p:cSld>
+    <p:spTree>
+      <p:nvGrpSpPr>
+        <p:cNvPr id="1" name=""/>
+        <p:cNvGrpSpPr/>
+        <p:nvPr/>
+      </p:nvGrpSpPr>
+      <p:grpSpPr/>
+      <p:pic>
+        <p:nvPicPr>
+          <p:cNvPr id="139" name="Google Shape;116;p21"/>
+          <p:cNvPicPr>
+            <a:picLocks noChangeAspect="1"/>
+          </p:cNvPicPr>
+          <p:nvPr/>
+        </p:nvPicPr>
+        <p:blipFill rotWithShape="1">
+          <a:blip r:embed="rId2">
+            <a:alphaModFix/>
+          </a:blip>
+          <a:srcRect l="0" t="0" r="0" b="98001"/>
+          <a:stretch/>
+        </p:blipFill>
+        <p:spPr>
+          <a:xfrm>
+            <a:off x="0" y="5093562"/>
+            <a:ext cx="9144000" cy="54275"/>
+          </a:xfrm>
+          <a:prstGeom prst="rect">
+            <a:avLst/>
+          </a:prstGeom>
+          <a:ln>
+            <a:noFill/>
+          </a:ln>
+        </p:spPr>
+      </p:pic>
+      <p:pic>
+        <p:nvPicPr>
+          <p:cNvPr id="140" name="Google Shape;117;p21"/>
+          <p:cNvPicPr>
+            <a:picLocks noChangeAspect="1"/>
+          </p:cNvPicPr>
+          <p:nvPr/>
+        </p:nvPicPr>
+        <p:blipFill>
+          <a:blip r:embed="rId3">
+            <a:alphaModFix/>
+          </a:blip>
+          <a:stretch>
+            <a:fillRect l="0" t="0" r="0" b="0"/>
+          </a:stretch>
+        </p:blipFill>
+        <p:spPr>
+          <a:xfrm>
+            <a:off x="0" y="1"/>
+            <a:ext cx="9144000" cy="507359"/>
+          </a:xfrm>
+          <a:prstGeom prst="rect">
+            <a:avLst/>
+          </a:prstGeom>
+          <a:ln>
+            <a:noFill/>
+          </a:ln>
+        </p:spPr>
+      </p:pic>
+      <p:sp>
+        <p:nvSpPr>
+          <p:cNvPr id="118" name="Google Shape;118;p21">
+            <a:extLst>
+              <a:ext uri="{FF2B5EF4-FFF2-40B4-BE49-F238E27FC236}">
+                <a16:creationId xmlns:a16="http://schemas.microsoft.com/office/drawing/2014/main" id="{90FAB6E9-1B1E-4AC3-8107-7514F14484D4}"/>
+              </a:ext>
+            </a:extLst>
+          </p:cNvPr>
+          <p:cNvSpPr>
+            <a:spLocks noGrp="1"/>
+          </p:cNvSpPr>
+          <p:nvPr/>
+        </p:nvSpPr>
+        <p:spPr>
+          <a:xfrm>
+            <a:off x="-29250" y="5071875"/>
+            <a:ext cx="9173400" cy="97800"/>
+          </a:xfrm>
+          <a:prstGeom prst="rect">
+            <a:avLst/>
+          </a:prstGeom>
+          <a:solidFill>
+            <a:schemeClr val="dk1"/>
+          </a:solidFill>
+          <a:ln>
+            <a:noFill/>
+          </a:ln>
+        </p:spPr>
+        <p:txBody>
+          <a:bodyPr spcFirstLastPara="1" wrap="square" lIns="91425" tIns="91425" rIns="91425" bIns="91425" anchor="ctr">
+            <a:noAutofit/>
+          </a:bodyPr>
+          <a:lstStyle/>
+          <a:p>
+            <a:pPr marL="0" lvl="0" indent="0" algn="ctr">
+              <a:spcBef>
+                <a:spcPts val="0"/>
+              </a:spcBef>
+              <a:spcAft>
+                <a:spcPts val="0"/>
+              </a:spcAft>
+              <a:buNone/>
+            </a:pPr>
+            <a:r>
+              <a:t/>
+            </a:r>
+            <a:endParaRPr/>
+          </a:p>
+        </p:txBody>
+      </p:sp>
+      <p:sp>
+        <p:nvSpPr>
+          <p:cNvPr id="119" name="Google Shape;119;p21">
+            <a:extLst>
+              <a:ext uri="{FF2B5EF4-FFF2-40B4-BE49-F238E27FC236}">
+                <a16:creationId xmlns:a16="http://schemas.microsoft.com/office/drawing/2014/main" id="{70EF1269-C4C4-4ABB-BEEE-D0867E087EA7}"/>
+              </a:ext>
+            </a:extLst>
+          </p:cNvPr>
+          <p:cNvSpPr>
+            <a:spLocks noGrp="1"/>
+          </p:cNvSpPr>
+          <p:nvPr/>
+        </p:nvSpPr>
+        <p:spPr>
+          <a:xfrm>
+            <a:off x="266700" y="676275"/>
+            <a:ext cx="8524875" cy="542925"/>
+          </a:xfrm>
+          <a:prstGeom prst="rect">
+            <a:avLst/>
+          </a:prstGeom>
+          <a:noFill/>
+          <a:ln>
+            <a:noFill/>
+          </a:ln>
+        </p:spPr>
+        <p:txBody>
+          <a:bodyPr spcFirstLastPara="1" wrap="square" lIns="0" tIns="0" rIns="0" bIns="0" anchor="t">
+            <a:normAutofit fontScale="100000"/>
+          </a:bodyPr>
+          <a:lstStyle/>
+          <a:p>
+            <a:pPr marL="0" lvl="0" indent="0" algn="l">
+              <a:spcBef>
+                <a:spcPts val="0"/>
+              </a:spcBef>
+              <a:spcAft>
+                <a:spcPts val="0"/>
+              </a:spcAft>
+              <a:buNone/>
+              <a:defRPr sz="1725">
+                <a:solidFill>
+                  <a:srgbClr val="161616"/>
+                </a:solidFill>
+                <a:latin typeface="Arial"/>
+                <a:ea typeface="Arial"/>
+                <a:cs typeface="Arial"/>
+              </a:defRPr>
+            </a:pPr>
+            <a:r>
+              <a:rPr sz="1725">
+                <a:solidFill>
+                  <a:srgbClr val="161616"/>
+                </a:solidFill>
+                <a:latin typeface="Arial"/>
+                <a:ea typeface="Arial"/>
+                <a:cs typeface="Arial"/>
+              </a:rPr>
+              <a:t>Trust built in: fraud prevention</a:t>
+            </a:r>
+            <a:endParaRPr sz="1600">
+              <a:latin typeface="Google Sans Flex Medium"/>
+              <a:ea typeface="Google Sans Flex Medium"/>
+              <a:cs typeface="Google Sans Flex Medium"/>
+            </a:endParaRPr>
+          </a:p>
+        </p:txBody>
+      </p:sp>
+      <p:sp>
+        <p:nvSpPr>
+          <p:cNvPr id="200" name="trust-label-0">
+            <a:extLst>
+              <a:ext uri="{FF2B5EF4-FFF2-40B4-BE49-F238E27FC236}">
+                <a16:creationId xmlns:a16="http://schemas.microsoft.com/office/drawing/2014/main" id="{FD321D03-A498-4D36-A747-32F9961F2285}"/>
+              </a:ext>
+            </a:extLst>
+          </p:cNvPr>
+          <p:cNvSpPr>
+            <a:spLocks noGrp="1"/>
+          </p:cNvSpPr>
+          <p:nvPr/>
+        </p:nvSpPr>
+        <p:spPr>
+          <a:xfrm>
+            <a:off x="523875" y="1400175"/>
+            <a:ext cx="2714625" cy="285750"/>
+          </a:xfrm>
+          <a:prstGeom prst="rect">
+            <a:avLst/>
+          </a:prstGeom>
+          <a:noFill/>
+          <a:ln w="0">
+            <a:noFill/>
+          </a:ln>
+        </p:spPr>
+        <p:txBody>
+          <a:bodyPr wrap="square" lIns="0" tIns="0" rIns="0" bIns="0" anchor="t">
+            <a:normAutofit fontScale="100000"/>
+          </a:bodyPr>
+          <a:lstStyle/>
+          <a:p>
+            <a:pPr>
+              <a:defRPr sz="1500" b="1">
+                <a:solidFill>
+                  <a:srgbClr val="161616"/>
+                </a:solidFill>
+                <a:latin typeface="Arial"/>
+                <a:ea typeface="Arial"/>
+                <a:cs typeface="Arial"/>
+              </a:defRPr>
+            </a:pPr>
+            <a:r>
+              <a:rPr sz="1500" b="1">
+                <a:solidFill>
+                  <a:srgbClr val="161616"/>
+                </a:solidFill>
+                <a:latin typeface="Arial"/>
+                <a:ea typeface="Arial"/>
+                <a:cs typeface="Arial"/>
+              </a:rPr>
+              <a:t>Pickup/booking pass</a:t>
+            </a:r>
+          </a:p>
+        </p:txBody>
+      </p:sp>
+      <p:sp>
+        <p:nvSpPr>
+          <p:cNvPr id="201" name="trust-desc-0">
+            <a:extLst>
+              <a:ext uri="{FF2B5EF4-FFF2-40B4-BE49-F238E27FC236}">
+                <a16:creationId xmlns:a16="http://schemas.microsoft.com/office/drawing/2014/main" id="{D75CB656-661E-4542-A438-C941DA210235}"/>
+              </a:ext>
+            </a:extLst>
+          </p:cNvPr>
+          <p:cNvSpPr>
+            <a:spLocks noGrp="1"/>
+          </p:cNvSpPr>
+          <p:nvPr/>
+        </p:nvSpPr>
+        <p:spPr>
+          <a:xfrm>
+            <a:off x="3324225" y="1400175"/>
+            <a:ext cx="5238750" cy="400050"/>
+          </a:xfrm>
+          <a:prstGeom prst="rect">
+            <a:avLst/>
+          </a:prstGeom>
+          <a:noFill/>
+          <a:ln w="0">
+            <a:noFill/>
+          </a:ln>
+        </p:spPr>
+        <p:txBody>
+          <a:bodyPr wrap="square" lIns="0" tIns="0" rIns="0" bIns="0" anchor="t">
+            <a:normAutofit fontScale="100000"/>
+          </a:bodyPr>
+          <a:lstStyle/>
+          <a:p>
+            <a:pPr>
+              <a:defRPr sz="1350" b="0">
+                <a:solidFill>
+                  <a:srgbClr val="444444"/>
+                </a:solidFill>
+                <a:latin typeface="Arial"/>
+                <a:ea typeface="Arial"/>
+                <a:cs typeface="Arial"/>
+              </a:defRPr>
+            </a:pPr>
+            <a:r>
+              <a:rPr sz="1350" b="0">
+                <a:solidFill>
+                  <a:srgbClr val="444444"/>
+                </a:solidFill>
+                <a:latin typeface="Arial"/>
+                <a:ea typeface="Arial"/>
+                <a:cs typeface="Arial"/>
+              </a:rPr>
+              <a:t>Second scan refused; the seller is matched by account</a:t>
+            </a:r>
+          </a:p>
+        </p:txBody>
+      </p:sp>
+      <p:sp>
+        <p:nvSpPr>
+          <p:cNvPr id="202" name="trust-rule-0">
+            <a:extLst>
+              <a:ext uri="{FF2B5EF4-FFF2-40B4-BE49-F238E27FC236}">
+                <a16:creationId xmlns:a16="http://schemas.microsoft.com/office/drawing/2014/main" id="{FC78AC28-F000-4B80-B03D-BB2D9F6AC8B7}"/>
+              </a:ext>
+            </a:extLst>
+          </p:cNvPr>
+          <p:cNvSpPr>
+            <a:spLocks noGrp="1"/>
+          </p:cNvSpPr>
+          <p:nvPr/>
+        </p:nvSpPr>
+        <p:spPr>
+          <a:xfrm>
+            <a:off x="523875" y="1819275"/>
+            <a:ext cx="8048625" cy="9525"/>
+          </a:xfrm>
+          <a:prstGeom prst="rect">
+            <a:avLst/>
+          </a:prstGeom>
+          <a:solidFill>
+            <a:srgbClr val="D8D8D8"/>
+          </a:solidFill>
+          <a:ln w="0">
+            <a:noFill/>
+          </a:ln>
+        </p:spPr>
+      </p:sp>
+      <p:sp>
+        <p:nvSpPr>
+          <p:cNvPr id="203" name="trust-label-1">
+            <a:extLst>
+              <a:ext uri="{FF2B5EF4-FFF2-40B4-BE49-F238E27FC236}">
+                <a16:creationId xmlns:a16="http://schemas.microsoft.com/office/drawing/2014/main" id="{306D714D-3713-4E36-99CE-710E4EA69727}"/>
+              </a:ext>
+            </a:extLst>
+          </p:cNvPr>
+          <p:cNvSpPr>
+            <a:spLocks noGrp="1"/>
+          </p:cNvSpPr>
+          <p:nvPr/>
+        </p:nvSpPr>
+        <p:spPr>
+          <a:xfrm>
+            <a:off x="523875" y="1876425"/>
+            <a:ext cx="2714625" cy="285750"/>
+          </a:xfrm>
+          <a:prstGeom prst="rect">
+            <a:avLst/>
+          </a:prstGeom>
+          <a:noFill/>
+          <a:ln w="0">
+            <a:noFill/>
+          </a:ln>
+        </p:spPr>
+        <p:txBody>
+          <a:bodyPr wrap="square" lIns="0" tIns="0" rIns="0" bIns="0" anchor="t">
+            <a:normAutofit fontScale="100000"/>
+          </a:bodyPr>
+          <a:lstStyle/>
+          <a:p>
+            <a:pPr>
+              <a:defRPr sz="1500" b="1">
+                <a:solidFill>
+                  <a:srgbClr val="161616"/>
+                </a:solidFill>
+                <a:latin typeface="Arial"/>
+                <a:ea typeface="Arial"/>
+                <a:cs typeface="Arial"/>
+              </a:defRPr>
+            </a:pPr>
+            <a:r>
+              <a:rPr sz="1500" b="1">
+                <a:solidFill>
+                  <a:srgbClr val="161616"/>
+                </a:solidFill>
+                <a:latin typeface="Arial"/>
+                <a:ea typeface="Arial"/>
+                <a:cs typeface="Arial"/>
+              </a:rPr>
+              <a:t>Signed receipts</a:t>
+            </a:r>
+          </a:p>
+        </p:txBody>
+      </p:sp>
+      <p:sp>
+        <p:nvSpPr>
+          <p:cNvPr id="204" name="trust-desc-1">
+            <a:extLst>
+              <a:ext uri="{FF2B5EF4-FFF2-40B4-BE49-F238E27FC236}">
+                <a16:creationId xmlns:a16="http://schemas.microsoft.com/office/drawing/2014/main" id="{E4B36518-440C-4DCC-B26D-4C2FF3468013}"/>
+              </a:ext>
+            </a:extLst>
+          </p:cNvPr>
+          <p:cNvSpPr>
+            <a:spLocks noGrp="1"/>
+          </p:cNvSpPr>
+          <p:nvPr/>
+        </p:nvSpPr>
+        <p:spPr>
+          <a:xfrm>
+            <a:off x="3324225" y="1876425"/>
+            <a:ext cx="5238750" cy="400050"/>
+          </a:xfrm>
+          <a:prstGeom prst="rect">
+            <a:avLst/>
+          </a:prstGeom>
+          <a:noFill/>
+          <a:ln w="0">
+            <a:noFill/>
+          </a:ln>
+        </p:spPr>
+        <p:txBody>
+          <a:bodyPr wrap="square" lIns="0" tIns="0" rIns="0" bIns="0" anchor="t">
+            <a:normAutofit fontScale="100000"/>
+          </a:bodyPr>
+          <a:lstStyle/>
+          <a:p>
+            <a:pPr>
+              <a:defRPr sz="1350" b="0">
+                <a:solidFill>
+                  <a:srgbClr val="444444"/>
+                </a:solidFill>
+                <a:latin typeface="Arial"/>
+                <a:ea typeface="Arial"/>
+                <a:cs typeface="Arial"/>
+              </a:defRPr>
+            </a:pPr>
+            <a:r>
+              <a:rPr sz="1350" b="0">
+                <a:solidFill>
+                  <a:srgbClr val="444444"/>
+                </a:solidFill>
+                <a:latin typeface="Arial"/>
+                <a:ea typeface="Arial"/>
+                <a:cs typeface="Arial"/>
+              </a:rPr>
+              <a:t>Ed25519-signed; any edit fails. Demo: “Try changing the price”</a:t>
+            </a:r>
+          </a:p>
+        </p:txBody>
+      </p:sp>
+      <p:sp>
+        <p:nvSpPr>
+          <p:cNvPr id="205" name="trust-rule-1">
+            <a:extLst>
+              <a:ext uri="{FF2B5EF4-FFF2-40B4-BE49-F238E27FC236}">
+                <a16:creationId xmlns:a16="http://schemas.microsoft.com/office/drawing/2014/main" id="{7FC6007B-C4A5-4369-972C-B6F2D8576849}"/>
+              </a:ext>
+            </a:extLst>
+          </p:cNvPr>
+          <p:cNvSpPr>
+            <a:spLocks noGrp="1"/>
+          </p:cNvSpPr>
+          <p:nvPr/>
+        </p:nvSpPr>
+        <p:spPr>
+          <a:xfrm>
+            <a:off x="523875" y="2295525"/>
+            <a:ext cx="8048625" cy="9525"/>
+          </a:xfrm>
+          <a:prstGeom prst="rect">
+            <a:avLst/>
+          </a:prstGeom>
+          <a:solidFill>
+            <a:srgbClr val="D8D8D8"/>
+          </a:solidFill>
+          <a:ln w="0">
+            <a:noFill/>
+          </a:ln>
+        </p:spPr>
+      </p:sp>
+      <p:sp>
+        <p:nvSpPr>
+          <p:cNvPr id="206" name="trust-label-2">
+            <a:extLst>
+              <a:ext uri="{FF2B5EF4-FFF2-40B4-BE49-F238E27FC236}">
+                <a16:creationId xmlns:a16="http://schemas.microsoft.com/office/drawing/2014/main" id="{1E2ADF80-DE49-4419-90BF-B51735CF84D9}"/>
+              </a:ext>
+            </a:extLst>
+          </p:cNvPr>
+          <p:cNvSpPr>
+            <a:spLocks noGrp="1"/>
+          </p:cNvSpPr>
+          <p:nvPr/>
+        </p:nvSpPr>
+        <p:spPr>
+          <a:xfrm>
+            <a:off x="523875" y="2352675"/>
+            <a:ext cx="2714625" cy="285750"/>
+          </a:xfrm>
+          <a:prstGeom prst="rect">
+            <a:avLst/>
+          </a:prstGeom>
+          <a:noFill/>
+          <a:ln w="0">
+            <a:noFill/>
+          </a:ln>
+        </p:spPr>
+        <p:txBody>
+          <a:bodyPr wrap="square" lIns="0" tIns="0" rIns="0" bIns="0" anchor="t">
+            <a:normAutofit fontScale="100000"/>
+          </a:bodyPr>
+          <a:lstStyle/>
+          <a:p>
+            <a:pPr>
+              <a:defRPr sz="1500" b="1">
+                <a:solidFill>
+                  <a:srgbClr val="161616"/>
+                </a:solidFill>
+                <a:latin typeface="Arial"/>
+                <a:ea typeface="Arial"/>
+                <a:cs typeface="Arial"/>
+              </a:defRPr>
+            </a:pPr>
+            <a:r>
+              <a:rPr sz="1500" b="1">
+                <a:solidFill>
+                  <a:srgbClr val="161616"/>
+                </a:solidFill>
+                <a:latin typeface="Arial"/>
+                <a:ea typeface="Arial"/>
+                <a:cs typeface="Arial"/>
+              </a:rPr>
+              <a:t>Model Armor</a:t>
+            </a:r>
+          </a:p>
+        </p:txBody>
+      </p:sp>
+      <p:sp>
+        <p:nvSpPr>
+          <p:cNvPr id="207" name="trust-desc-2">
+            <a:extLst>
+              <a:ext uri="{FF2B5EF4-FFF2-40B4-BE49-F238E27FC236}">
+                <a16:creationId xmlns:a16="http://schemas.microsoft.com/office/drawing/2014/main" id="{E8FA3B8F-4642-416B-A5C4-555C93DD5035}"/>
+              </a:ext>
+            </a:extLst>
+          </p:cNvPr>
+          <p:cNvSpPr>
+            <a:spLocks noGrp="1"/>
+          </p:cNvSpPr>
+          <p:nvPr/>
+        </p:nvSpPr>
+        <p:spPr>
+          <a:xfrm>
+            <a:off x="3324225" y="2352675"/>
+            <a:ext cx="5238750" cy="400050"/>
+          </a:xfrm>
+          <a:prstGeom prst="rect">
+            <a:avLst/>
+          </a:prstGeom>
+          <a:noFill/>
+          <a:ln w="0">
+            <a:noFill/>
+          </a:ln>
+        </p:spPr>
+        <p:txBody>
+          <a:bodyPr wrap="square" lIns="0" tIns="0" rIns="0" bIns="0" anchor="t">
+            <a:normAutofit fontScale="100000"/>
+          </a:bodyPr>
+          <a:lstStyle/>
+          <a:p>
+            <a:pPr>
+              <a:defRPr sz="1350" b="0">
+                <a:solidFill>
+                  <a:srgbClr val="444444"/>
+                </a:solidFill>
+                <a:latin typeface="Arial"/>
+                <a:ea typeface="Arial"/>
+                <a:cs typeface="Arial"/>
+              </a:defRPr>
+            </a:pPr>
+            <a:r>
+              <a:rPr sz="1350" b="0">
+                <a:solidFill>
+                  <a:srgbClr val="444444"/>
+                </a:solidFill>
+                <a:latin typeface="Arial"/>
+                <a:ea typeface="Arial"/>
+                <a:cs typeface="Arial"/>
+              </a:rPr>
+              <a:t>Screens every message from other agents for prompt injection</a:t>
+            </a:r>
+          </a:p>
+        </p:txBody>
+      </p:sp>
+      <p:sp>
+        <p:nvSpPr>
+          <p:cNvPr id="208" name="trust-rule-2">
+            <a:extLst>
+              <a:ext uri="{FF2B5EF4-FFF2-40B4-BE49-F238E27FC236}">
+                <a16:creationId xmlns:a16="http://schemas.microsoft.com/office/drawing/2014/main" id="{5C17DB77-BE48-49C7-9722-FAEA26B2820B}"/>
+              </a:ext>
+            </a:extLst>
+          </p:cNvPr>
+          <p:cNvSpPr>
+            <a:spLocks noGrp="1"/>
+          </p:cNvSpPr>
+          <p:nvPr/>
+        </p:nvSpPr>
+        <p:spPr>
+          <a:xfrm>
+            <a:off x="523875" y="2771775"/>
+            <a:ext cx="8048625" cy="9525"/>
+          </a:xfrm>
+          <a:prstGeom prst="rect">
+            <a:avLst/>
+          </a:prstGeom>
+          <a:solidFill>
+            <a:srgbClr val="D8D8D8"/>
+          </a:solidFill>
+          <a:ln w="0">
+            <a:noFill/>
+          </a:ln>
+        </p:spPr>
+      </p:sp>
+      <p:sp>
+        <p:nvSpPr>
+          <p:cNvPr id="209" name="trust-label-3">
+            <a:extLst>
+              <a:ext uri="{FF2B5EF4-FFF2-40B4-BE49-F238E27FC236}">
+                <a16:creationId xmlns:a16="http://schemas.microsoft.com/office/drawing/2014/main" id="{6606DE32-A264-4C34-9AA0-D2608F344A0F}"/>
+              </a:ext>
+            </a:extLst>
+          </p:cNvPr>
+          <p:cNvSpPr>
+            <a:spLocks noGrp="1"/>
+          </p:cNvSpPr>
+          <p:nvPr/>
+        </p:nvSpPr>
+        <p:spPr>
+          <a:xfrm>
+            <a:off x="523875" y="2828925"/>
+            <a:ext cx="2714625" cy="285750"/>
+          </a:xfrm>
+          <a:prstGeom prst="rect">
+            <a:avLst/>
+          </a:prstGeom>
+          <a:noFill/>
+          <a:ln w="0">
+            <a:noFill/>
+          </a:ln>
+        </p:spPr>
+        <p:txBody>
+          <a:bodyPr wrap="square" lIns="0" tIns="0" rIns="0" bIns="0" anchor="t">
+            <a:normAutofit fontScale="100000"/>
+          </a:bodyPr>
+          <a:lstStyle/>
+          <a:p>
+            <a:pPr>
+              <a:defRPr sz="1500" b="1">
+                <a:solidFill>
+                  <a:srgbClr val="161616"/>
+                </a:solidFill>
+                <a:latin typeface="Arial"/>
+                <a:ea typeface="Arial"/>
+                <a:cs typeface="Arial"/>
+              </a:defRPr>
+            </a:pPr>
+            <a:r>
+              <a:rPr sz="1500" b="1">
+                <a:solidFill>
+                  <a:srgbClr val="161616"/>
+                </a:solidFill>
+                <a:latin typeface="Arial"/>
+                <a:ea typeface="Arial"/>
+                <a:cs typeface="Arial"/>
+              </a:rPr>
+              <a:t>No overselling</a:t>
+            </a:r>
+          </a:p>
+        </p:txBody>
+      </p:sp>
+      <p:sp>
+        <p:nvSpPr>
+          <p:cNvPr id="210" name="trust-desc-3">
+            <a:extLst>
+              <a:ext uri="{FF2B5EF4-FFF2-40B4-BE49-F238E27FC236}">
+                <a16:creationId xmlns:a16="http://schemas.microsoft.com/office/drawing/2014/main" id="{37D2A817-21B7-4522-A73F-056BD95468FA}"/>
+              </a:ext>
+            </a:extLst>
+          </p:cNvPr>
+          <p:cNvSpPr>
+            <a:spLocks noGrp="1"/>
+          </p:cNvSpPr>
+          <p:nvPr/>
+        </p:nvSpPr>
+        <p:spPr>
+          <a:xfrm>
+            <a:off x="3324225" y="2828925"/>
+            <a:ext cx="5238750" cy="400050"/>
+          </a:xfrm>
+          <a:prstGeom prst="rect">
+            <a:avLst/>
+          </a:prstGeom>
+          <a:noFill/>
+          <a:ln w="0">
+            <a:noFill/>
+          </a:ln>
+        </p:spPr>
+        <p:txBody>
+          <a:bodyPr wrap="square" lIns="0" tIns="0" rIns="0" bIns="0" anchor="t">
+            <a:normAutofit fontScale="100000"/>
+          </a:bodyPr>
+          <a:lstStyle/>
+          <a:p>
+            <a:pPr>
+              <a:defRPr sz="1350" b="0">
+                <a:solidFill>
+                  <a:srgbClr val="444444"/>
+                </a:solidFill>
+                <a:latin typeface="Arial"/>
+                <a:ea typeface="Arial"/>
+                <a:cs typeface="Arial"/>
+              </a:defRPr>
+            </a:pPr>
+            <a:r>
+              <a:rPr sz="1350" b="0">
+                <a:solidFill>
+                  <a:srgbClr val="444444"/>
+                </a:solidFill>
+                <a:latin typeface="Arial"/>
+                <a:ea typeface="Arial"/>
+                <a:cs typeface="Arial"/>
+              </a:rPr>
+              <a:t>Per-buyer limits and atomic stock holds</a:t>
+            </a:r>
+          </a:p>
+        </p:txBody>
+      </p:sp>
+      <p:sp>
+        <p:nvSpPr>
+          <p:cNvPr id="211" name="trust-rule-3">
+            <a:extLst>
+              <a:ext uri="{FF2B5EF4-FFF2-40B4-BE49-F238E27FC236}">
+                <a16:creationId xmlns:a16="http://schemas.microsoft.com/office/drawing/2014/main" id="{6DA57FBA-32BC-4A96-93AE-1893C01314E8}"/>
+              </a:ext>
+            </a:extLst>
+          </p:cNvPr>
+          <p:cNvSpPr>
+            <a:spLocks noGrp="1"/>
+          </p:cNvSpPr>
+          <p:nvPr/>
+        </p:nvSpPr>
+        <p:spPr>
+          <a:xfrm>
+            <a:off x="523875" y="3248025"/>
+            <a:ext cx="8048625" cy="9525"/>
+          </a:xfrm>
+          <a:prstGeom prst="rect">
+            <a:avLst/>
+          </a:prstGeom>
+          <a:solidFill>
+            <a:srgbClr val="D8D8D8"/>
+          </a:solidFill>
+          <a:ln w="0">
+            <a:noFill/>
+          </a:ln>
+        </p:spPr>
+      </p:sp>
+      <p:sp>
+        <p:nvSpPr>
+          <p:cNvPr id="212" name="trust-label-4">
+            <a:extLst>
+              <a:ext uri="{FF2B5EF4-FFF2-40B4-BE49-F238E27FC236}">
+                <a16:creationId xmlns:a16="http://schemas.microsoft.com/office/drawing/2014/main" id="{4DA1622D-B8DF-40A3-B2A6-CAEC0CD79027}"/>
+              </a:ext>
+            </a:extLst>
+          </p:cNvPr>
+          <p:cNvSpPr>
+            <a:spLocks noGrp="1"/>
+          </p:cNvSpPr>
+          <p:nvPr/>
+        </p:nvSpPr>
+        <p:spPr>
+          <a:xfrm>
+            <a:off x="523875" y="3305175"/>
+            <a:ext cx="2714625" cy="285750"/>
+          </a:xfrm>
+          <a:prstGeom prst="rect">
+            <a:avLst/>
+          </a:prstGeom>
+          <a:noFill/>
+          <a:ln w="0">
+            <a:noFill/>
+          </a:ln>
+        </p:spPr>
+        <p:txBody>
+          <a:bodyPr wrap="square" lIns="0" tIns="0" rIns="0" bIns="0" anchor="t">
+            <a:normAutofit fontScale="100000"/>
+          </a:bodyPr>
+          <a:lstStyle/>
+          <a:p>
+            <a:pPr>
+              <a:defRPr sz="1500" b="1">
+                <a:solidFill>
+                  <a:srgbClr val="161616"/>
+                </a:solidFill>
+                <a:latin typeface="Arial"/>
+                <a:ea typeface="Arial"/>
+                <a:cs typeface="Arial"/>
+              </a:defRPr>
+            </a:pPr>
+            <a:r>
+              <a:rPr sz="1500" b="1">
+                <a:solidFill>
+                  <a:srgbClr val="161616"/>
+                </a:solidFill>
+                <a:latin typeface="Arial"/>
+                <a:ea typeface="Arial"/>
+                <a:cs typeface="Arial"/>
+              </a:rPr>
+              <a:t>Seller record</a:t>
+            </a:r>
+          </a:p>
+        </p:txBody>
+      </p:sp>
+      <p:sp>
+        <p:nvSpPr>
+          <p:cNvPr id="213" name="trust-desc-4">
+            <a:extLst>
+              <a:ext uri="{FF2B5EF4-FFF2-40B4-BE49-F238E27FC236}">
+                <a16:creationId xmlns:a16="http://schemas.microsoft.com/office/drawing/2014/main" id="{4FA94DED-7A0B-410F-8873-6BBCB4B6A911}"/>
+              </a:ext>
+            </a:extLst>
+          </p:cNvPr>
+          <p:cNvSpPr>
+            <a:spLocks noGrp="1"/>
+          </p:cNvSpPr>
+          <p:nvPr/>
+        </p:nvSpPr>
+        <p:spPr>
+          <a:xfrm>
+            <a:off x="3324225" y="3305175"/>
+            <a:ext cx="5238750" cy="400050"/>
+          </a:xfrm>
+          <a:prstGeom prst="rect">
+            <a:avLst/>
+          </a:prstGeom>
+          <a:noFill/>
+          <a:ln w="0">
+            <a:noFill/>
+          </a:ln>
+        </p:spPr>
+        <p:txBody>
+          <a:bodyPr wrap="square" lIns="0" tIns="0" rIns="0" bIns="0" anchor="t">
+            <a:normAutofit fontScale="100000"/>
+          </a:bodyPr>
+          <a:lstStyle/>
+          <a:p>
+            <a:pPr>
+              <a:defRPr sz="1350" b="0">
+                <a:solidFill>
+                  <a:srgbClr val="444444"/>
+                </a:solidFill>
+                <a:latin typeface="Arial"/>
+                <a:ea typeface="Arial"/>
+                <a:cs typeface="Arial"/>
+              </a:defRPr>
+            </a:pPr>
+            <a:r>
+              <a:rPr sz="1350" b="0">
+                <a:solidFill>
+                  <a:srgbClr val="444444"/>
+                </a:solidFill>
+                <a:latin typeface="Arial"/>
+                <a:ea typeface="Arial"/>
+                <a:cs typeface="Arial"/>
+              </a:rPr>
+              <a:t>Public record counts problems from signed receipts</a:t>
+            </a:r>
+          </a:p>
+        </p:txBody>
+      </p:sp>
+      <p:sp>
+        <p:nvSpPr>
+          <p:cNvPr id="214" name="trust-rule-4">
+            <a:extLst>
+              <a:ext uri="{FF2B5EF4-FFF2-40B4-BE49-F238E27FC236}">
+                <a16:creationId xmlns:a16="http://schemas.microsoft.com/office/drawing/2014/main" id="{BD9C8BD4-63D6-4B52-A903-DCCE1D91C5D8}"/>
+              </a:ext>
+            </a:extLst>
+          </p:cNvPr>
+          <p:cNvSpPr>
+            <a:spLocks noGrp="1"/>
+          </p:cNvSpPr>
+          <p:nvPr/>
+        </p:nvSpPr>
+        <p:spPr>
+          <a:xfrm>
+            <a:off x="523875" y="3724275"/>
+            <a:ext cx="8048625" cy="9525"/>
+          </a:xfrm>
+          <a:prstGeom prst="rect">
+            <a:avLst/>
+          </a:prstGeom>
+          <a:solidFill>
+            <a:srgbClr val="D8D8D8"/>
+          </a:solidFill>
+          <a:ln w="0">
+            <a:noFill/>
+          </a:ln>
+        </p:spPr>
+      </p:sp>
+      <p:sp>
+        <p:nvSpPr>
+          <p:cNvPr id="215" name="trust-label-5">
+            <a:extLst>
+              <a:ext uri="{FF2B5EF4-FFF2-40B4-BE49-F238E27FC236}">
+                <a16:creationId xmlns:a16="http://schemas.microsoft.com/office/drawing/2014/main" id="{7F7FC35F-157B-4123-B8F2-874FA6076F18}"/>
+              </a:ext>
+            </a:extLst>
+          </p:cNvPr>
+          <p:cNvSpPr>
+            <a:spLocks noGrp="1"/>
+          </p:cNvSpPr>
+          <p:nvPr/>
+        </p:nvSpPr>
+        <p:spPr>
+          <a:xfrm>
+            <a:off x="523875" y="3781425"/>
+            <a:ext cx="2714625" cy="285750"/>
+          </a:xfrm>
+          <a:prstGeom prst="rect">
+            <a:avLst/>
+          </a:prstGeom>
+          <a:noFill/>
+          <a:ln w="0">
+            <a:noFill/>
+          </a:ln>
+        </p:spPr>
+        <p:txBody>
+          <a:bodyPr wrap="square" lIns="0" tIns="0" rIns="0" bIns="0" anchor="t">
+            <a:normAutofit fontScale="100000"/>
+          </a:bodyPr>
+          <a:lstStyle/>
+          <a:p>
+            <a:pPr>
+              <a:defRPr sz="1500" b="1">
+                <a:solidFill>
+                  <a:srgbClr val="161616"/>
+                </a:solidFill>
+                <a:latin typeface="Arial"/>
+                <a:ea typeface="Arial"/>
+                <a:cs typeface="Arial"/>
+              </a:defRPr>
+            </a:pPr>
+            <a:r>
+              <a:rPr sz="1500" b="1">
+                <a:solidFill>
+                  <a:srgbClr val="161616"/>
+                </a:solidFill>
+                <a:latin typeface="Arial"/>
+                <a:ea typeface="Arial"/>
+                <a:cs typeface="Arial"/>
+              </a:rPr>
+              <a:t>App Check</a:t>
+            </a:r>
+          </a:p>
+        </p:txBody>
+      </p:sp>
+      <p:sp>
+        <p:nvSpPr>
+          <p:cNvPr id="216" name="trust-desc-5">
+            <a:extLst>
+              <a:ext uri="{FF2B5EF4-FFF2-40B4-BE49-F238E27FC236}">
+                <a16:creationId xmlns:a16="http://schemas.microsoft.com/office/drawing/2014/main" id="{2029E64E-53AE-495C-8A70-0255D58920E6}"/>
+              </a:ext>
+            </a:extLst>
+          </p:cNvPr>
+          <p:cNvSpPr>
+            <a:spLocks noGrp="1"/>
+          </p:cNvSpPr>
+          <p:nvPr/>
+        </p:nvSpPr>
+        <p:spPr>
+          <a:xfrm>
+            <a:off x="3324225" y="3781425"/>
+            <a:ext cx="5238750" cy="400050"/>
+          </a:xfrm>
+          <a:prstGeom prst="rect">
+            <a:avLst/>
+          </a:prstGeom>
+          <a:noFill/>
+          <a:ln w="0">
+            <a:noFill/>
+          </a:ln>
+        </p:spPr>
+        <p:txBody>
+          <a:bodyPr wrap="square" lIns="0" tIns="0" rIns="0" bIns="0" anchor="t">
+            <a:normAutofit fontScale="100000"/>
+          </a:bodyPr>
+          <a:lstStyle/>
+          <a:p>
+            <a:pPr>
+              <a:defRPr sz="1350" b="0">
+                <a:solidFill>
+                  <a:srgbClr val="444444"/>
+                </a:solidFill>
+                <a:latin typeface="Arial"/>
+                <a:ea typeface="Arial"/>
+                <a:cs typeface="Arial"/>
+              </a:defRPr>
+            </a:pPr>
+            <a:r>
+              <a:rPr sz="1350" b="0">
+                <a:solidFill>
+                  <a:srgbClr val="444444"/>
+                </a:solidFill>
+                <a:latin typeface="Arial"/>
+                <a:ea typeface="Arial"/>
+                <a:cs typeface="Arial"/>
+              </a:rPr>
+              <a:t>Checks every write; unverified browsers are rate-limited</a:t>
+            </a:r>
+          </a:p>
+        </p:txBody>
+      </p:sp>
+      <p:sp>
+        <p:nvSpPr>
+          <p:cNvPr id="217" name="trust-rule-5">
+            <a:extLst>
+              <a:ext uri="{FF2B5EF4-FFF2-40B4-BE49-F238E27FC236}">
+                <a16:creationId xmlns:a16="http://schemas.microsoft.com/office/drawing/2014/main" id="{6C65EBE2-8D16-4D24-BFD7-953FDFE208D6}"/>
+              </a:ext>
+            </a:extLst>
+          </p:cNvPr>
+          <p:cNvSpPr>
+            <a:spLocks noGrp="1"/>
+          </p:cNvSpPr>
+          <p:nvPr/>
+        </p:nvSpPr>
+        <p:spPr>
+          <a:xfrm>
+            <a:off x="523875" y="4200525"/>
+            <a:ext cx="8048625" cy="9525"/>
+          </a:xfrm>
+          <a:prstGeom prst="rect">
+            <a:avLst/>
+          </a:prstGeom>
+          <a:solidFill>
+            <a:srgbClr val="D8D8D8"/>
+          </a:solidFill>
+          <a:ln w="0">
+            <a:noFill/>
+          </a:ln>
+        </p:spPr>
+      </p:sp>
+      <p:sp>
+        <p:nvSpPr>
+          <p:cNvPr id="218" name="trust-label-6">
+            <a:extLst>
+              <a:ext uri="{FF2B5EF4-FFF2-40B4-BE49-F238E27FC236}">
+                <a16:creationId xmlns:a16="http://schemas.microsoft.com/office/drawing/2014/main" id="{ADEB4F0F-A210-41C3-8C88-79CE64E51AA9}"/>
+              </a:ext>
+            </a:extLst>
+          </p:cNvPr>
+          <p:cNvSpPr>
+            <a:spLocks noGrp="1"/>
+          </p:cNvSpPr>
+          <p:nvPr/>
+        </p:nvSpPr>
+        <p:spPr>
+          <a:xfrm>
+            <a:off x="523875" y="4257675"/>
+            <a:ext cx="2714625" cy="285750"/>
+          </a:xfrm>
+          <a:prstGeom prst="rect">
+            <a:avLst/>
+          </a:prstGeom>
+          <a:noFill/>
+          <a:ln w="0">
+            <a:noFill/>
+          </a:ln>
+        </p:spPr>
+        <p:txBody>
+          <a:bodyPr wrap="square" lIns="0" tIns="0" rIns="0" bIns="0" anchor="t">
+            <a:normAutofit fontScale="100000"/>
+          </a:bodyPr>
+          <a:lstStyle/>
+          <a:p>
+            <a:pPr>
+              <a:defRPr sz="1500" b="1">
+                <a:solidFill>
+                  <a:srgbClr val="161616"/>
+                </a:solidFill>
+                <a:latin typeface="Arial"/>
+                <a:ea typeface="Arial"/>
+                <a:cs typeface="Arial"/>
+              </a:defRPr>
+            </a:pPr>
+            <a:r>
+              <a:rPr sz="1500" b="1">
+                <a:solidFill>
+                  <a:srgbClr val="161616"/>
+                </a:solidFill>
+                <a:latin typeface="Arial"/>
+                <a:ea typeface="Arial"/>
+                <a:cs typeface="Arial"/>
+              </a:rPr>
+              <a:t>Demo payments</a:t>
+            </a:r>
+          </a:p>
+        </p:txBody>
+      </p:sp>
+      <p:sp>
+        <p:nvSpPr>
+          <p:cNvPr id="219" name="trust-desc-6">
+            <a:extLst>
+              <a:ext uri="{FF2B5EF4-FFF2-40B4-BE49-F238E27FC236}">
+                <a16:creationId xmlns:a16="http://schemas.microsoft.com/office/drawing/2014/main" id="{D15180C2-1A42-424E-96A1-79006A17B70A}"/>
+              </a:ext>
+            </a:extLst>
+          </p:cNvPr>
+          <p:cNvSpPr>
+            <a:spLocks noGrp="1"/>
+          </p:cNvSpPr>
+          <p:nvPr/>
+        </p:nvSpPr>
+        <p:spPr>
+          <a:xfrm>
+            <a:off x="3324225" y="4257675"/>
+            <a:ext cx="5238750" cy="400050"/>
+          </a:xfrm>
+          <a:prstGeom prst="rect">
+            <a:avLst/>
+          </a:prstGeom>
+          <a:noFill/>
+          <a:ln w="0">
+            <a:noFill/>
+          </a:ln>
+        </p:spPr>
+        <p:txBody>
+          <a:bodyPr wrap="square" lIns="0" tIns="0" rIns="0" bIns="0" anchor="t">
+            <a:normAutofit fontScale="100000"/>
+          </a:bodyPr>
+          <a:lstStyle/>
+          <a:p>
+            <a:pPr>
+              <a:defRPr sz="1350" b="0">
+                <a:solidFill>
+                  <a:srgbClr val="444444"/>
+                </a:solidFill>
+                <a:latin typeface="Arial"/>
+                <a:ea typeface="Arial"/>
+                <a:cs typeface="Arial"/>
+              </a:defRPr>
+            </a:pPr>
+            <a:r>
+              <a:rPr sz="1350" b="0">
+                <a:solidFill>
+                  <a:srgbClr val="444444"/>
+                </a:solidFill>
+                <a:latin typeface="Arial"/>
+                <a:ea typeface="Arial"/>
+                <a:cs typeface="Arial"/>
+              </a:rPr>
+              <a:t>Clearly tagged test mode; no real money moves</a:t>
+            </a:r>
+          </a:p>
+        </p:txBody>
+      </p:sp>
+    </p:spTree>
+  </p:cSld>
+  <p:clrMapOvr>
+    <a:masterClrMapping/>
+  </p:clrMapOvr>
+</p:sld>
+</file>
+
 <file path=ppt/slides/slide2.xml><?xml version="1.0" encoding="utf-8"?>
 <p:sld xmlns:p="http://schemas.openxmlformats.org/presentationml/2006/main">
   <p:cSld>

</xml_diff>